<commit_message>
Regret curves: show only the maps the tables show
The figure drew every map in the results directory, so root1, relu, abs,
clip_c2 and sum appeared there and nowhere else in the document -- a reader
counting panels against Tables 4 and 5 found 21 against 16.  Default the
exclusion set to tables.EXCLUDED and drop k>1 maps, which have their own
subsection, and say so in the caption.

Co-Authored-By: Claude Opus 5 <noreply@anthropic.com>
</commit_message>
<xml_diff>
--- a/slides/composite_matern.pptx
+++ b/slides/composite_matern.pptx
@@ -10316,8 +10316,8 @@
         </p:blipFill>
         <p:spPr>
           <a:xfrm>
-            <a:off x="2165698" y="1325880"/>
-            <a:ext cx="7860298" cy="5394960"/>
+            <a:off x="900360" y="1325880"/>
+            <a:ext cx="10390975" cy="5394960"/>
           </a:xfrm>
           <a:prstGeom prst="rect">
             <a:avLst/>

</xml_diff>